<commit_message>
feat(formula): 论文升级 v5.9.11 - GitHub 真实代码移植 (DDM/SDT/ActiveInference-G)
P1 真实论文代码: wfpt_py (Bogacz 2006) + pymdp (Friston 2013)
P2-P4 移植: ddmDecisionTime/ddmErrorRate, sdtDPrime/sdtBeta/sdtAPrime, activeInferenceInfoGain
P5 收口: matcher 触发词 85->91; 集成测试 21/21; FormulaBridge 69->75; FormulaRegistry 68->74
</commit_message>
<xml_diff>
--- a/docs/formula-matching-slide.pptx
+++ b/docs/formula-matching-slide.pptx
@@ -3547,7 +3547,7 @@
                         <a:defRPr sz="900"/>
                       </a:pPr>
                       <a:r>
-                        <a:t>选择、决策、取舍、博弈、冲突、纳什均衡、零和、pennies</a:t>
+                        <a:t>选择、决策、取舍、博弈、冲突、纳什均衡、零和、pennies、决策时间、反应时、漂移率、决策动力学、扩散模型、信号检测、辨别力、虚报率、命中率</a:t>
                       </a:r>
                     </a:p>
                   </a:txBody>
@@ -3618,6 +3618,31 @@
                     <a:p>
                       <a:r>
                         <a:t>• matching_pennies (stage-primitive)</a:t>
+                      </a:r>
+                    </a:p>
+                    <a:p>
+                      <a:r>
+                        <a:t>• ddm_decision_time (stage-primitive)</a:t>
+                      </a:r>
+                    </a:p>
+                    <a:p>
+                      <a:r>
+                        <a:t>• ddm_error_rate (stage-primitive)</a:t>
+                      </a:r>
+                    </a:p>
+                    <a:p>
+                      <a:r>
+                        <a:t>• sdt_d_prime (stage-primitive)</a:t>
+                      </a:r>
+                    </a:p>
+                    <a:p>
+                      <a:r>
+                        <a:t>• sdt_beta (stage-primitive)</a:t>
+                      </a:r>
+                    </a:p>
+                    <a:p>
+                      <a:r>
+                        <a:t>• sdt_a_prime (stage-primitive)</a:t>
                       </a:r>
                     </a:p>
                   </a:txBody>
@@ -4254,6 +4279,21 @@
                         <a:t>• 期望效用(动机权衡)</a:t>
                       </a:r>
                     </a:p>
+                    <a:p>
+                      <a:r>
+                        <a:t>• sdt_d_prime (stage-primitive)</a:t>
+                      </a:r>
+                    </a:p>
+                    <a:p>
+                      <a:r>
+                        <a:t>• sdt_beta (stage-primitive)</a:t>
+                      </a:r>
+                    </a:p>
+                    <a:p>
+                      <a:r>
+                        <a:t>• sdt_a_prime (stage-primitive)</a:t>
+                      </a:r>
+                    </a:p>
                   </a:txBody>
                   <a:tcPr anchor="t">
                     <a:solidFill>
@@ -4569,7 +4609,7 @@
                         <a:defRPr sz="900"/>
                       </a:pPr>
                       <a:r>
-                        <a:t>自由能、预测误差、主动推断、最小化惊奇</a:t>
+                        <a:t>自由能、预测误差、主动推断、最小化惊奇、预期自由能、信息增益、认识性价值</a:t>
                       </a:r>
                     </a:p>
                   </a:txBody>
@@ -4595,6 +4635,11 @@
                     <a:p>
                       <a:r>
                         <a:t>• precision_weight (stage-primitive)</a:t>
+                      </a:r>
+                    </a:p>
+                    <a:p>
+                      <a:r>
+                        <a:t>• aif_info_gain (stage-primitive)</a:t>
                       </a:r>
                     </a:p>
                   </a:txBody>

</xml_diff>